<commit_message>
prepa Prez test 2
</commit_message>
<xml_diff>
--- a/JPA-HIBERNATE.pptx
+++ b/JPA-HIBERNATE.pptx
@@ -5,10 +5,10 @@
     <p:sldMasterId id="2147483660" r:id="rId4"/>
   </p:sldMasterIdLst>
   <p:notesMasterIdLst>
-    <p:notesMasterId r:id="rId35"/>
+    <p:notesMasterId r:id="rId36"/>
   </p:notesMasterIdLst>
   <p:handoutMasterIdLst>
-    <p:handoutMasterId r:id="rId36"/>
+    <p:handoutMasterId r:id="rId37"/>
   </p:handoutMasterIdLst>
   <p:sldIdLst>
     <p:sldId id="256" r:id="rId5"/>
@@ -41,6 +41,7 @@
     <p:sldId id="326" r:id="rId32"/>
     <p:sldId id="306" r:id="rId33"/>
     <p:sldId id="299" r:id="rId34"/>
+    <p:sldId id="327" r:id="rId35"/>
   </p:sldIdLst>
   <p:sldSz cx="12192000" cy="6858000"/>
   <p:notesSz cx="6858000" cy="9144000"/>
@@ -174,6 +175,7 @@
             <p14:sldId id="326"/>
             <p14:sldId id="306"/>
             <p14:sldId id="299"/>
+            <p14:sldId id="327"/>
           </p14:sldIdLst>
         </p14:section>
       </p14:sectionLst>
@@ -1173,6 +1175,14 @@
           <a:bodyPr/>
           <a:lstStyle/>
           <a:p>
+            <a:r>
+              <a:rPr lang="fr-FR" noProof="1"/>
+              <a:t>Vous aurez un erreur type qui vons indiquera si la session est fermée : </a:t>
+            </a:r>
+            <a:r>
+              <a:rPr lang="en-US" noProof="1"/>
+              <a:t>failed to lazily initialize a collection of role</a:t>
+            </a:r>
             <a:endParaRPr lang="fr-FR" noProof="1"/>
           </a:p>
         </p:txBody>
@@ -1344,499 +1354,46 @@
           <a:lstStyle/>
           <a:p>
             <a:r>
-              <a:rPr lang="en-US" dirty="0">
-                <a:solidFill>
-                  <a:srgbClr val="0033B3"/>
-                </a:solidFill>
-                <a:effectLst/>
-              </a:rPr>
-              <a:t>select </a:t>
-            </a:r>
-            <a:r>
-              <a:rPr lang="en-US" dirty="0">
-                <a:solidFill>
-                  <a:srgbClr val="000000"/>
-                </a:solidFill>
-                <a:effectLst/>
-              </a:rPr>
-              <a:t>teachers0_</a:t>
-            </a:r>
-            <a:r>
-              <a:rPr lang="en-US" dirty="0"/>
-              <a:t>.</a:t>
-            </a:r>
-            <a:r>
-              <a:rPr lang="en-US" dirty="0">
-                <a:solidFill>
-                  <a:srgbClr val="871094"/>
-                </a:solidFill>
-                <a:effectLst/>
-              </a:rPr>
-              <a:t>school_id </a:t>
-            </a:r>
-            <a:r>
-              <a:rPr lang="en-US" dirty="0">
-                <a:solidFill>
-                  <a:srgbClr val="0033B3"/>
-                </a:solidFill>
-                <a:effectLst/>
-              </a:rPr>
-              <a:t>as </a:t>
-            </a:r>
-            <a:r>
-              <a:rPr lang="en-US" dirty="0">
-                <a:solidFill>
-                  <a:srgbClr val="000000"/>
-                </a:solidFill>
-                <a:effectLst/>
-              </a:rPr>
-              <a:t>school_i3_4_1_</a:t>
-            </a:r>
-            <a:r>
-              <a:rPr lang="en-US" dirty="0"/>
-              <a:t>,</a:t>
-            </a:r>
-            <a:br>
-              <a:rPr lang="en-US" dirty="0"/>
-            </a:br>
-            <a:r>
-              <a:rPr lang="en-US" dirty="0"/>
-              <a:t>       </a:t>
-            </a:r>
-            <a:r>
-              <a:rPr lang="en-US" dirty="0">
-                <a:solidFill>
-                  <a:srgbClr val="000000"/>
-                </a:solidFill>
-                <a:effectLst/>
-              </a:rPr>
-              <a:t>teachers0_</a:t>
-            </a:r>
-            <a:r>
-              <a:rPr lang="en-US" dirty="0"/>
-              <a:t>.</a:t>
-            </a:r>
-            <a:r>
-              <a:rPr lang="en-US" dirty="0">
-                <a:solidFill>
-                  <a:srgbClr val="871094"/>
-                </a:solidFill>
-                <a:effectLst/>
-              </a:rPr>
-              <a:t>id        </a:t>
-            </a:r>
-            <a:r>
-              <a:rPr lang="en-US" dirty="0">
-                <a:solidFill>
-                  <a:srgbClr val="0033B3"/>
-                </a:solidFill>
-                <a:effectLst/>
-              </a:rPr>
-              <a:t>as </a:t>
-            </a:r>
-            <a:r>
-              <a:rPr lang="en-US" dirty="0">
-                <a:solidFill>
-                  <a:srgbClr val="000000"/>
-                </a:solidFill>
-                <a:effectLst/>
-              </a:rPr>
-              <a:t>id1_4_1_</a:t>
-            </a:r>
-            <a:r>
-              <a:rPr lang="en-US" dirty="0"/>
-              <a:t>,</a:t>
-            </a:r>
-            <a:br>
-              <a:rPr lang="en-US" dirty="0"/>
-            </a:br>
-            <a:r>
-              <a:rPr lang="en-US" dirty="0"/>
-              <a:t>       </a:t>
-            </a:r>
-            <a:r>
-              <a:rPr lang="en-US" dirty="0">
-                <a:solidFill>
-                  <a:srgbClr val="000000"/>
-                </a:solidFill>
-                <a:effectLst/>
-              </a:rPr>
-              <a:t>teachers0_</a:t>
-            </a:r>
-            <a:r>
-              <a:rPr lang="en-US" dirty="0"/>
-              <a:t>.</a:t>
-            </a:r>
-            <a:r>
-              <a:rPr lang="en-US" dirty="0">
-                <a:solidFill>
-                  <a:srgbClr val="871094"/>
-                </a:solidFill>
-                <a:effectLst/>
-              </a:rPr>
-              <a:t>id        </a:t>
-            </a:r>
-            <a:r>
-              <a:rPr lang="en-US" dirty="0">
-                <a:solidFill>
-                  <a:srgbClr val="0033B3"/>
-                </a:solidFill>
-                <a:effectLst/>
-              </a:rPr>
-              <a:t>as </a:t>
-            </a:r>
-            <a:r>
-              <a:rPr lang="en-US" dirty="0">
-                <a:solidFill>
-                  <a:srgbClr val="000000"/>
-                </a:solidFill>
-                <a:effectLst/>
-              </a:rPr>
-              <a:t>id1_4_0_</a:t>
-            </a:r>
-            <a:r>
-              <a:rPr lang="en-US" dirty="0"/>
-              <a:t>,</a:t>
-            </a:r>
-            <a:br>
-              <a:rPr lang="en-US" dirty="0"/>
-            </a:br>
-            <a:r>
-              <a:rPr lang="en-US" dirty="0"/>
-              <a:t>       </a:t>
-            </a:r>
-            <a:r>
-              <a:rPr lang="en-US" dirty="0">
-                <a:solidFill>
-                  <a:srgbClr val="000000"/>
-                </a:solidFill>
-                <a:effectLst/>
-              </a:rPr>
-              <a:t>teachers0_</a:t>
-            </a:r>
-            <a:r>
-              <a:rPr lang="en-US" dirty="0"/>
-              <a:t>.</a:t>
-            </a:r>
-            <a:r>
-              <a:rPr lang="en-US" dirty="0">
-                <a:solidFill>
-                  <a:srgbClr val="871094"/>
-                </a:solidFill>
-                <a:effectLst/>
-              </a:rPr>
-              <a:t>name      </a:t>
-            </a:r>
-            <a:r>
-              <a:rPr lang="en-US" dirty="0">
-                <a:solidFill>
-                  <a:srgbClr val="0033B3"/>
-                </a:solidFill>
-                <a:effectLst/>
-              </a:rPr>
-              <a:t>as </a:t>
-            </a:r>
-            <a:r>
-              <a:rPr lang="en-US" dirty="0">
-                <a:solidFill>
-                  <a:srgbClr val="000000"/>
-                </a:solidFill>
-                <a:effectLst/>
-              </a:rPr>
-              <a:t>name2_4_0_</a:t>
-            </a:r>
-            <a:r>
-              <a:rPr lang="en-US" dirty="0"/>
-              <a:t>,</a:t>
-            </a:r>
-            <a:br>
-              <a:rPr lang="en-US" dirty="0"/>
-            </a:br>
-            <a:r>
-              <a:rPr lang="en-US" dirty="0"/>
-              <a:t>       </a:t>
-            </a:r>
-            <a:r>
-              <a:rPr lang="en-US" dirty="0">
-                <a:solidFill>
-                  <a:srgbClr val="000000"/>
-                </a:solidFill>
-                <a:effectLst/>
-              </a:rPr>
-              <a:t>teachers0_</a:t>
-            </a:r>
-            <a:r>
-              <a:rPr lang="en-US" dirty="0"/>
-              <a:t>.</a:t>
-            </a:r>
-            <a:r>
-              <a:rPr lang="en-US" dirty="0">
-                <a:solidFill>
-                  <a:srgbClr val="871094"/>
-                </a:solidFill>
-                <a:effectLst/>
-              </a:rPr>
-              <a:t>school_id </a:t>
-            </a:r>
-            <a:r>
-              <a:rPr lang="en-US" dirty="0">
-                <a:solidFill>
-                  <a:srgbClr val="0033B3"/>
-                </a:solidFill>
-                <a:effectLst/>
-              </a:rPr>
-              <a:t>as </a:t>
-            </a:r>
-            <a:r>
-              <a:rPr lang="en-US" dirty="0">
-                <a:solidFill>
-                  <a:srgbClr val="000000"/>
-                </a:solidFill>
-                <a:effectLst/>
-              </a:rPr>
-              <a:t>school_i3_4_0_</a:t>
-            </a:r>
-            <a:br>
-              <a:rPr lang="en-US" dirty="0">
-                <a:solidFill>
-                  <a:srgbClr val="000000"/>
-                </a:solidFill>
-                <a:effectLst/>
-              </a:rPr>
-            </a:br>
-            <a:r>
-              <a:rPr lang="en-US" dirty="0">
-                <a:solidFill>
-                  <a:srgbClr val="0033B3"/>
-                </a:solidFill>
-                <a:effectLst/>
-              </a:rPr>
-              <a:t>from </a:t>
-            </a:r>
-            <a:r>
-              <a:rPr lang="en-US" dirty="0">
-                <a:solidFill>
-                  <a:srgbClr val="000000"/>
-                </a:solidFill>
-                <a:effectLst/>
-              </a:rPr>
-              <a:t>teacher teachers0_</a:t>
-            </a:r>
-            <a:br>
-              <a:rPr lang="en-US" dirty="0">
-                <a:solidFill>
-                  <a:srgbClr val="000000"/>
-                </a:solidFill>
-                <a:effectLst/>
-              </a:rPr>
-            </a:br>
-            <a:r>
-              <a:rPr lang="en-US" dirty="0">
-                <a:solidFill>
-                  <a:srgbClr val="0033B3"/>
-                </a:solidFill>
-                <a:effectLst/>
-              </a:rPr>
-              <a:t>where </a:t>
-            </a:r>
-            <a:r>
-              <a:rPr lang="en-US" dirty="0">
-                <a:solidFill>
-                  <a:srgbClr val="000000"/>
-                </a:solidFill>
-                <a:effectLst/>
-              </a:rPr>
-              <a:t>teachers0_</a:t>
-            </a:r>
-            <a:r>
-              <a:rPr lang="en-US" dirty="0"/>
-              <a:t>.</a:t>
-            </a:r>
-            <a:r>
-              <a:rPr lang="en-US" dirty="0">
-                <a:solidFill>
-                  <a:srgbClr val="871094"/>
-                </a:solidFill>
-                <a:effectLst/>
-              </a:rPr>
-              <a:t>school_id </a:t>
-            </a:r>
-            <a:r>
-              <a:rPr lang="en-US" dirty="0">
-                <a:solidFill>
-                  <a:srgbClr val="0033B3"/>
-                </a:solidFill>
-                <a:effectLst/>
-              </a:rPr>
-              <a:t>in </a:t>
-            </a:r>
-            <a:r>
-              <a:rPr lang="en-US" dirty="0"/>
-              <a:t>(</a:t>
-            </a:r>
-            <a:r>
-              <a:rPr lang="en-US" dirty="0">
-                <a:solidFill>
-                  <a:srgbClr val="0033B3"/>
-                </a:solidFill>
-                <a:effectLst/>
-              </a:rPr>
-              <a:t>select </a:t>
-            </a:r>
-            <a:r>
-              <a:rPr lang="en-US" dirty="0">
-                <a:solidFill>
-                  <a:srgbClr val="000000"/>
-                </a:solidFill>
-                <a:effectLst/>
-              </a:rPr>
-              <a:t>school0_</a:t>
-            </a:r>
-            <a:r>
-              <a:rPr lang="en-US" dirty="0"/>
-              <a:t>.</a:t>
-            </a:r>
-            <a:r>
-              <a:rPr lang="en-US" dirty="0">
-                <a:solidFill>
-                  <a:srgbClr val="871094"/>
-                </a:solidFill>
-                <a:effectLst/>
-              </a:rPr>
-              <a:t>id</a:t>
-            </a:r>
-            <a:br>
-              <a:rPr lang="en-US" dirty="0">
-                <a:solidFill>
-                  <a:srgbClr val="871094"/>
-                </a:solidFill>
-                <a:effectLst/>
-              </a:rPr>
-            </a:br>
-            <a:r>
-              <a:rPr lang="en-US" dirty="0">
-                <a:solidFill>
-                  <a:srgbClr val="871094"/>
-                </a:solidFill>
-                <a:effectLst/>
-              </a:rPr>
-              <a:t>                               </a:t>
-            </a:r>
-            <a:r>
-              <a:rPr lang="en-US" dirty="0">
-                <a:solidFill>
-                  <a:srgbClr val="0033B3"/>
-                </a:solidFill>
-                <a:effectLst/>
-              </a:rPr>
-              <a:t>from </a:t>
-            </a:r>
-            <a:r>
-              <a:rPr lang="en-US" dirty="0">
-                <a:solidFill>
-                  <a:srgbClr val="000000"/>
-                </a:solidFill>
-                <a:effectLst/>
-              </a:rPr>
-              <a:t>school school0_</a:t>
-            </a:r>
-            <a:br>
-              <a:rPr lang="en-US" dirty="0">
-                <a:solidFill>
-                  <a:srgbClr val="000000"/>
-                </a:solidFill>
-                <a:effectLst/>
-              </a:rPr>
-            </a:br>
-            <a:r>
-              <a:rPr lang="en-US" dirty="0">
-                <a:solidFill>
-                  <a:srgbClr val="000000"/>
-                </a:solidFill>
-                <a:effectLst/>
-              </a:rPr>
-              <a:t>                                        </a:t>
-            </a:r>
-            <a:r>
-              <a:rPr lang="en-US" dirty="0">
-                <a:solidFill>
-                  <a:srgbClr val="0033B3"/>
-                </a:solidFill>
-                <a:effectLst/>
-              </a:rPr>
-              <a:t>inner join </a:t>
-            </a:r>
-            <a:r>
-              <a:rPr lang="en-US" dirty="0">
-                <a:solidFill>
-                  <a:srgbClr val="000000"/>
-                </a:solidFill>
-                <a:effectLst/>
-              </a:rPr>
-              <a:t>director director1_ </a:t>
-            </a:r>
-            <a:r>
-              <a:rPr lang="en-US" dirty="0">
-                <a:solidFill>
-                  <a:srgbClr val="0033B3"/>
-                </a:solidFill>
-                <a:effectLst/>
-              </a:rPr>
-              <a:t>on </a:t>
-            </a:r>
-            <a:r>
-              <a:rPr lang="en-US" dirty="0">
-                <a:solidFill>
-                  <a:srgbClr val="000000"/>
-                </a:solidFill>
-                <a:effectLst/>
-              </a:rPr>
-              <a:t>school0_</a:t>
-            </a:r>
-            <a:r>
-              <a:rPr lang="en-US" dirty="0"/>
-              <a:t>.</a:t>
-            </a:r>
-            <a:r>
-              <a:rPr lang="en-US" dirty="0">
-                <a:solidFill>
-                  <a:srgbClr val="871094"/>
-                </a:solidFill>
-                <a:effectLst/>
-              </a:rPr>
-              <a:t>director_id </a:t>
-            </a:r>
-            <a:r>
-              <a:rPr lang="en-US" dirty="0"/>
-              <a:t>= </a:t>
-            </a:r>
-            <a:r>
-              <a:rPr lang="en-US" dirty="0">
-                <a:solidFill>
-                  <a:srgbClr val="000000"/>
-                </a:solidFill>
-                <a:effectLst/>
-              </a:rPr>
-              <a:t>director1_</a:t>
-            </a:r>
-            <a:r>
-              <a:rPr lang="en-US" dirty="0"/>
-              <a:t>.</a:t>
-            </a:r>
-            <a:r>
-              <a:rPr lang="en-US" dirty="0">
-                <a:solidFill>
-                  <a:srgbClr val="871094"/>
-                </a:solidFill>
-                <a:effectLst/>
-              </a:rPr>
-              <a:t>id</a:t>
-            </a:r>
-            <a:r>
-              <a:rPr lang="en-US" dirty="0"/>
-              <a:t>)</a:t>
+              <a:rPr lang="fr-FR" noProof="1"/>
+              <a:t>Defaut : fonctionne très bien sur la récupération d’une seule entité, mais dès lors que l’on veut récupérer une liste avec ou sans pagination, nous arons bcp de N+1</a:t>
+            </a:r>
+          </a:p>
+          <a:p>
+            <a:r>
+              <a:rPr lang="fr-FR" noProof="1"/>
+              <a:t>En plusieurs fois : finalement ce que l’on veut c’est pouvoir faire notre récupération de données en utilisant le mapping relationnel de nos entités et non le faire à la main</a:t>
+            </a:r>
+          </a:p>
+          <a:p>
+            <a:r>
+              <a:rPr lang="fr-FR" noProof="1"/>
+              <a:t>BatchSize : On va réduire le nombre de requête et on en aura autant que dans le cas par défaut mais quelque soit le nombre d’entités que l’on récupère (pour peu qu’il soit inférieur à x)</a:t>
+            </a:r>
+          </a:p>
+          <a:p>
+            <a:r>
+              <a:rPr lang="fr-FR" noProof="1"/>
+              <a:t>SubSelect : On aura de façon certaine une seule requête par relation, car au lieu d’avoir where id in (…) on aura un id in (subselect)</a:t>
+            </a:r>
+          </a:p>
+          <a:p>
+            <a:r>
+              <a:rPr lang="fr-FR" noProof="1"/>
+              <a:t>FETCH : il est déclaratif lors de la requête, donc pas dans le code c’est pour cette raison que l’ incompatibilité est en vert </a:t>
+            </a:r>
+            <a:r>
+              <a:rPr lang="fr-FR" noProof="1">
+                <a:sym typeface="Wingdings" panose="05000000000000000000" pitchFamily="2" charset="2"/>
+              </a:rPr>
+              <a:t></a:t>
             </a:r>
             <a:endParaRPr lang="fr-FR" noProof="1"/>
+          </a:p>
+          <a:p>
+            <a:r>
+              <a:rPr lang="fr-FR" noProof="1"/>
+              <a:t>JPQL : Java Persistence Query Langage</a:t>
+            </a:r>
           </a:p>
         </p:txBody>
       </p:sp>
@@ -1923,7 +1480,7 @@
           <a:p>
             <a:r>
               <a:rPr lang="fr-FR" noProof="1"/>
-              <a:t>Pas de BatchSize sur les relations OneToOne</a:t>
+              <a:t>Pas de BatchSize sur les relations OneToOne !!</a:t>
             </a:r>
           </a:p>
         </p:txBody>
@@ -2040,7 +1597,53 @@
             </a:pPr>
             <a:r>
               <a:rPr lang="fr-FR" noProof="1"/>
-              <a:t>Pas de BatchSize sur les relations OneToOne</a:t>
+              <a:t>A mettre d’office sur toutes les relations OneToOne</a:t>
+            </a:r>
+          </a:p>
+          <a:p>
+            <a:pPr marL="0" marR="0" lvl="0" indent="0" algn="l" defTabSz="914400" rtl="0" eaLnBrk="1" fontAlgn="auto" latinLnBrk="0" hangingPunct="1">
+              <a:lnSpc>
+                <a:spcPct val="100000"/>
+              </a:lnSpc>
+              <a:spcBef>
+                <a:spcPts val="0"/>
+              </a:spcBef>
+              <a:spcAft>
+                <a:spcPts val="0"/>
+              </a:spcAft>
+              <a:buClrTx/>
+              <a:buSzTx/>
+              <a:buFontTx/>
+              <a:buNone/>
+              <a:tabLst/>
+              <a:defRPr/>
+            </a:pPr>
+            <a:r>
+              <a:rPr lang="fr-FR" noProof="1"/>
+              <a:t>Le produit cartesien pour une ou quelque grappe est bien meilleur que les autres solutions car ça ne fait qu’un seul SELECT.</a:t>
+            </a:r>
+          </a:p>
+          <a:p>
+            <a:pPr marL="0" marR="0" lvl="0" indent="0" algn="l" defTabSz="914400" rtl="0" eaLnBrk="1" fontAlgn="auto" latinLnBrk="0" hangingPunct="1">
+              <a:lnSpc>
+                <a:spcPct val="100000"/>
+              </a:lnSpc>
+              <a:spcBef>
+                <a:spcPts val="0"/>
+              </a:spcBef>
+              <a:spcAft>
+                <a:spcPts val="0"/>
+              </a:spcAft>
+              <a:buClrTx/>
+              <a:buSzTx/>
+              <a:buFontTx/>
+              <a:buNone/>
+              <a:tabLst/>
+              <a:defRPr/>
+            </a:pPr>
+            <a:r>
+              <a:rPr lang="fr-FR" noProof="1"/>
+              <a:t>Et pour des temps aussi courts, c’est l’aller retour server BDD qui va compter le plus.</a:t>
             </a:r>
           </a:p>
           <a:p>
@@ -2214,7 +1817,10 @@
           <a:bodyPr/>
           <a:lstStyle/>
           <a:p>
-            <a:endParaRPr lang="fr-FR" noProof="1"/>
+            <a:r>
+              <a:rPr lang="fr-FR" noProof="1"/>
+              <a:t>Avec les batch size = taille de page sur les entités xxxToMany, on est pas mal mais on peut faire encore un peu mieux !</a:t>
+            </a:r>
           </a:p>
         </p:txBody>
       </p:sp>
@@ -2509,7 +2115,33 @@
           <a:bodyPr/>
           <a:lstStyle/>
           <a:p>
-            <a:endParaRPr lang="fr-FR" noProof="1"/>
+            <a:r>
+              <a:rPr lang="fr-FR" dirty="0"/>
+              <a:t>Maintenant on passe un peu aux choses sérieuses </a:t>
+            </a:r>
+            <a:r>
+              <a:rPr lang="fr-FR" dirty="0">
+                <a:sym typeface="Wingdings" panose="05000000000000000000" pitchFamily="2" charset="2"/>
+              </a:rPr>
+              <a:t></a:t>
+            </a:r>
+          </a:p>
+          <a:p>
+            <a:r>
+              <a:rPr lang="fr-FR" dirty="0">
+                <a:sym typeface="Wingdings" panose="05000000000000000000" pitchFamily="2" charset="2"/>
+              </a:rPr>
+              <a:t>Tout à l’heure j’ai dit que FETCHER les données n’était pas compatible avec la pagination !</a:t>
+            </a:r>
+          </a:p>
+          <a:p>
+            <a:r>
+              <a:rPr lang="fr-FR" dirty="0">
+                <a:sym typeface="Wingdings" panose="05000000000000000000" pitchFamily="2" charset="2"/>
+              </a:rPr>
+              <a:t>Avec une seule requête je peux faire planter le serveur !</a:t>
+            </a:r>
+            <a:endParaRPr lang="fr-FR" dirty="0"/>
           </a:p>
         </p:txBody>
       </p:sp>
@@ -2530,8 +2162,8 @@
           <a:p>
             <a:pPr rtl="0"/>
             <a:fld id="{DF61EA0F-A667-4B49-8422-0062BC55E249}" type="slidenum">
-              <a:rPr lang="fr-FR" noProof="1" dirty="0" smtClean="0"/>
-              <a:t>22</a:t>
+              <a:rPr lang="fr-FR" noProof="1" smtClean="0"/>
+              <a:t>21</a:t>
             </a:fld>
             <a:endParaRPr lang="fr-FR" noProof="1"/>
           </a:p>
@@ -2540,7 +2172,7 @@
     </p:spTree>
     <p:extLst>
       <p:ext uri="{BB962C8B-B14F-4D97-AF65-F5344CB8AC3E}">
-        <p14:creationId xmlns:p14="http://schemas.microsoft.com/office/powerpoint/2010/main" val="2685482423"/>
+        <p14:creationId xmlns:p14="http://schemas.microsoft.com/office/powerpoint/2010/main" val="1644808820"/>
       </p:ext>
     </p:extLst>
   </p:cSld>
@@ -2594,7 +2226,10 @@
           <a:bodyPr/>
           <a:lstStyle/>
           <a:p>
-            <a:endParaRPr lang="fr-FR" noProof="1"/>
+            <a:r>
+              <a:rPr lang="fr-FR" noProof="1"/>
+              <a:t>On ne peut pas utiliser une entité pour récupérer le résultat, mais le mapping sera fait automatiquement par le système via une projection</a:t>
+            </a:r>
           </a:p>
         </p:txBody>
       </p:sp>
@@ -2616,7 +2251,7 @@
             <a:pPr rtl="0"/>
             <a:fld id="{DF61EA0F-A667-4B49-8422-0062BC55E249}" type="slidenum">
               <a:rPr lang="fr-FR" noProof="1" dirty="0" smtClean="0"/>
-              <a:t>23</a:t>
+              <a:t>22</a:t>
             </a:fld>
             <a:endParaRPr lang="fr-FR" noProof="1"/>
           </a:p>
@@ -2625,7 +2260,7 @@
     </p:spTree>
     <p:extLst>
       <p:ext uri="{BB962C8B-B14F-4D97-AF65-F5344CB8AC3E}">
-        <p14:creationId xmlns:p14="http://schemas.microsoft.com/office/powerpoint/2010/main" val="3804920323"/>
+        <p14:creationId xmlns:p14="http://schemas.microsoft.com/office/powerpoint/2010/main" val="2685482423"/>
       </p:ext>
     </p:extLst>
   </p:cSld>
@@ -2701,7 +2336,7 @@
             <a:pPr rtl="0"/>
             <a:fld id="{DF61EA0F-A667-4B49-8422-0062BC55E249}" type="slidenum">
               <a:rPr lang="fr-FR" noProof="1" dirty="0" smtClean="0"/>
-              <a:t>24</a:t>
+              <a:t>23</a:t>
             </a:fld>
             <a:endParaRPr lang="fr-FR" noProof="1"/>
           </a:p>
@@ -2710,7 +2345,7 @@
     </p:spTree>
     <p:extLst>
       <p:ext uri="{BB962C8B-B14F-4D97-AF65-F5344CB8AC3E}">
-        <p14:creationId xmlns:p14="http://schemas.microsoft.com/office/powerpoint/2010/main" val="2263289659"/>
+        <p14:creationId xmlns:p14="http://schemas.microsoft.com/office/powerpoint/2010/main" val="3804920323"/>
       </p:ext>
     </p:extLst>
   </p:cSld>
@@ -2764,7 +2399,16 @@
           <a:bodyPr/>
           <a:lstStyle/>
           <a:p>
-            <a:endParaRPr lang="fr-FR" noProof="1"/>
+            <a:r>
+              <a:rPr lang="fr-FR" noProof="1"/>
+              <a:t>Le résultat est le même dans les deux cas, je récupère un object ou une liste d’objets remplis avec le résultat de la requete</a:t>
+            </a:r>
+          </a:p>
+          <a:p>
+            <a:r>
+              <a:rPr lang="fr-FR" noProof="1"/>
+              <a:t>Petite note sur le fait que ces objects peuvent sortir des controllers car ils ne sont pas liés au modèle de données et correspondent à un besoin métier précis</a:t>
+            </a:r>
           </a:p>
         </p:txBody>
       </p:sp>
@@ -2786,7 +2430,7 @@
             <a:pPr rtl="0"/>
             <a:fld id="{DF61EA0F-A667-4B49-8422-0062BC55E249}" type="slidenum">
               <a:rPr lang="fr-FR" noProof="1" dirty="0" smtClean="0"/>
-              <a:t>25</a:t>
+              <a:t>24</a:t>
             </a:fld>
             <a:endParaRPr lang="fr-FR" noProof="1"/>
           </a:p>
@@ -2795,7 +2439,7 @@
     </p:spTree>
     <p:extLst>
       <p:ext uri="{BB962C8B-B14F-4D97-AF65-F5344CB8AC3E}">
-        <p14:creationId xmlns:p14="http://schemas.microsoft.com/office/powerpoint/2010/main" val="512973995"/>
+        <p14:creationId xmlns:p14="http://schemas.microsoft.com/office/powerpoint/2010/main" val="2263289659"/>
       </p:ext>
     </p:extLst>
   </p:cSld>
@@ -2871,7 +2515,7 @@
             <a:pPr rtl="0"/>
             <a:fld id="{DF61EA0F-A667-4B49-8422-0062BC55E249}" type="slidenum">
               <a:rPr lang="fr-FR" noProof="1" dirty="0" smtClean="0"/>
-              <a:t>26</a:t>
+              <a:t>25</a:t>
             </a:fld>
             <a:endParaRPr lang="fr-FR" noProof="1"/>
           </a:p>
@@ -2880,7 +2524,7 @@
     </p:spTree>
     <p:extLst>
       <p:ext uri="{BB962C8B-B14F-4D97-AF65-F5344CB8AC3E}">
-        <p14:creationId xmlns:p14="http://schemas.microsoft.com/office/powerpoint/2010/main" val="2015775768"/>
+        <p14:creationId xmlns:p14="http://schemas.microsoft.com/office/powerpoint/2010/main" val="512973995"/>
       </p:ext>
     </p:extLst>
   </p:cSld>
@@ -2956,7 +2600,7 @@
             <a:pPr rtl="0"/>
             <a:fld id="{DF61EA0F-A667-4B49-8422-0062BC55E249}" type="slidenum">
               <a:rPr lang="fr-FR" noProof="1" dirty="0" smtClean="0"/>
-              <a:t>27</a:t>
+              <a:t>26</a:t>
             </a:fld>
             <a:endParaRPr lang="fr-FR" noProof="1"/>
           </a:p>
@@ -2965,7 +2609,7 @@
     </p:spTree>
     <p:extLst>
       <p:ext uri="{BB962C8B-B14F-4D97-AF65-F5344CB8AC3E}">
-        <p14:creationId xmlns:p14="http://schemas.microsoft.com/office/powerpoint/2010/main" val="1067624400"/>
+        <p14:creationId xmlns:p14="http://schemas.microsoft.com/office/powerpoint/2010/main" val="2015775768"/>
       </p:ext>
     </p:extLst>
   </p:cSld>
@@ -3019,7 +2663,50 @@
           <a:bodyPr/>
           <a:lstStyle/>
           <a:p>
-            <a:endParaRPr lang="fr-FR" noProof="1"/>
+            <a:pPr marL="0" marR="0" lvl="0" indent="0" algn="l" defTabSz="914400" rtl="0" eaLnBrk="1" fontAlgn="auto" latinLnBrk="0" hangingPunct="1">
+              <a:lnSpc>
+                <a:spcPct val="100000"/>
+              </a:lnSpc>
+              <a:spcBef>
+                <a:spcPts val="0"/>
+              </a:spcBef>
+              <a:spcAft>
+                <a:spcPts val="0"/>
+              </a:spcAft>
+              <a:buClrTx/>
+              <a:buSzTx/>
+              <a:buFontTx/>
+              <a:buNone/>
+              <a:tabLst/>
+              <a:defRPr/>
+            </a:pPr>
+            <a:r>
+              <a:rPr lang="fr-FR" noProof="1"/>
+              <a:t>Dès que vous souhaitez récupérer des listes très grandes (avec pagination de préférence), utiliser les annotations</a:t>
+            </a:r>
+          </a:p>
+          <a:p>
+            <a:pPr marL="0" marR="0" lvl="0" indent="0" algn="l" defTabSz="914400" rtl="0" eaLnBrk="1" fontAlgn="auto" latinLnBrk="0" hangingPunct="1">
+              <a:lnSpc>
+                <a:spcPct val="100000"/>
+              </a:lnSpc>
+              <a:spcBef>
+                <a:spcPts val="0"/>
+              </a:spcBef>
+              <a:spcAft>
+                <a:spcPts val="0"/>
+              </a:spcAft>
+              <a:buClrTx/>
+              <a:buSzTx/>
+              <a:buFontTx/>
+              <a:buNone/>
+              <a:tabLst/>
+              <a:defRPr/>
+            </a:pPr>
+            <a:r>
+              <a:rPr lang="fr-FR" noProof="1"/>
+              <a:t>Et en plus ça reste copmpatible avec le cas précédent !</a:t>
+            </a:r>
           </a:p>
         </p:txBody>
       </p:sp>
@@ -3041,7 +2728,7 @@
             <a:pPr rtl="0"/>
             <a:fld id="{DF61EA0F-A667-4B49-8422-0062BC55E249}" type="slidenum">
               <a:rPr lang="fr-FR" noProof="1" dirty="0" smtClean="0"/>
-              <a:t>28</a:t>
+              <a:t>27</a:t>
             </a:fld>
             <a:endParaRPr lang="fr-FR" noProof="1"/>
           </a:p>
@@ -3050,7 +2737,7 @@
     </p:spTree>
     <p:extLst>
       <p:ext uri="{BB962C8B-B14F-4D97-AF65-F5344CB8AC3E}">
-        <p14:creationId xmlns:p14="http://schemas.microsoft.com/office/powerpoint/2010/main" val="2446949418"/>
+        <p14:creationId xmlns:p14="http://schemas.microsoft.com/office/powerpoint/2010/main" val="1067624400"/>
       </p:ext>
     </p:extLst>
   </p:cSld>
@@ -3126,7 +2813,7 @@
             <a:pPr rtl="0"/>
             <a:fld id="{DF61EA0F-A667-4B49-8422-0062BC55E249}" type="slidenum">
               <a:rPr lang="fr-FR" noProof="1" dirty="0" smtClean="0"/>
-              <a:t>29</a:t>
+              <a:t>28</a:t>
             </a:fld>
             <a:endParaRPr lang="fr-FR" noProof="1"/>
           </a:p>
@@ -3135,7 +2822,7 @@
     </p:spTree>
     <p:extLst>
       <p:ext uri="{BB962C8B-B14F-4D97-AF65-F5344CB8AC3E}">
-        <p14:creationId xmlns:p14="http://schemas.microsoft.com/office/powerpoint/2010/main" val="198457126"/>
+        <p14:creationId xmlns:p14="http://schemas.microsoft.com/office/powerpoint/2010/main" val="2446949418"/>
       </p:ext>
     </p:extLst>
   </p:cSld>
@@ -3189,6 +2876,18 @@
           <a:bodyPr/>
           <a:lstStyle/>
           <a:p>
+            <a:r>
+              <a:rPr lang="fr-FR" noProof="1"/>
+              <a:t>Le premier properties est utile, j’en reparle dans le slide suivant !</a:t>
+            </a:r>
+          </a:p>
+          <a:p>
+            <a:r>
+              <a:rPr lang="fr-FR" noProof="1"/>
+              <a:t>Open in view va vous permettre de détecter plus facilement les N+1</a:t>
+            </a:r>
+          </a:p>
+          <a:p>
             <a:endParaRPr lang="fr-FR" noProof="1"/>
           </a:p>
         </p:txBody>
@@ -3211,7 +2910,7 @@
             <a:pPr rtl="0"/>
             <a:fld id="{DF61EA0F-A667-4B49-8422-0062BC55E249}" type="slidenum">
               <a:rPr lang="fr-FR" noProof="1" dirty="0" smtClean="0"/>
-              <a:t>30</a:t>
+              <a:t>29</a:t>
             </a:fld>
             <a:endParaRPr lang="fr-FR" noProof="1"/>
           </a:p>
@@ -3220,7 +2919,7 @@
     </p:spTree>
     <p:extLst>
       <p:ext uri="{BB962C8B-B14F-4D97-AF65-F5344CB8AC3E}">
-        <p14:creationId xmlns:p14="http://schemas.microsoft.com/office/powerpoint/2010/main" val="1359022272"/>
+        <p14:creationId xmlns:p14="http://schemas.microsoft.com/office/powerpoint/2010/main" val="198457126"/>
       </p:ext>
     </p:extLst>
   </p:cSld>
@@ -3323,6 +3022,176 @@
     <p:extLst>
       <p:ext uri="{BB962C8B-B14F-4D97-AF65-F5344CB8AC3E}">
         <p14:creationId xmlns:p14="http://schemas.microsoft.com/office/powerpoint/2010/main" val="976932870"/>
+      </p:ext>
+    </p:extLst>
+  </p:cSld>
+  <p:clrMapOvr>
+    <a:masterClrMapping/>
+  </p:clrMapOvr>
+</p:notes>
+</file>
+
+<file path=ppt/notesSlides/notesSlide30.xml><?xml version="1.0" encoding="utf-8"?>
+<p:notes xmlns:a="http://schemas.openxmlformats.org/drawingml/2006/main" xmlns:r="http://schemas.openxmlformats.org/officeDocument/2006/relationships" xmlns:p="http://schemas.openxmlformats.org/presentationml/2006/main">
+  <p:cSld>
+    <p:spTree>
+      <p:nvGrpSpPr>
+        <p:cNvPr id="1" name=""/>
+        <p:cNvGrpSpPr/>
+        <p:nvPr/>
+      </p:nvGrpSpPr>
+      <p:grpSpPr>
+        <a:xfrm>
+          <a:off x="0" y="0"/>
+          <a:ext cx="0" cy="0"/>
+          <a:chOff x="0" y="0"/>
+          <a:chExt cx="0" cy="0"/>
+        </a:xfrm>
+      </p:grpSpPr>
+      <p:sp>
+        <p:nvSpPr>
+          <p:cNvPr id="2" name="Espace réservé de l'image des diapositives 1"/>
+          <p:cNvSpPr>
+            <a:spLocks noGrp="1" noRot="1" noChangeAspect="1"/>
+          </p:cNvSpPr>
+          <p:nvPr>
+            <p:ph type="sldImg"/>
+          </p:nvPr>
+        </p:nvSpPr>
+        <p:spPr/>
+      </p:sp>
+      <p:sp>
+        <p:nvSpPr>
+          <p:cNvPr id="3" name="Espace réservé des notes 2"/>
+          <p:cNvSpPr>
+            <a:spLocks noGrp="1"/>
+          </p:cNvSpPr>
+          <p:nvPr>
+            <p:ph type="body" idx="1"/>
+          </p:nvPr>
+        </p:nvSpPr>
+        <p:spPr/>
+        <p:txBody>
+          <a:bodyPr/>
+          <a:lstStyle/>
+          <a:p>
+            <a:endParaRPr lang="fr-FR" noProof="1"/>
+          </a:p>
+        </p:txBody>
+      </p:sp>
+      <p:sp>
+        <p:nvSpPr>
+          <p:cNvPr id="4" name="Espace réservé du numéro de diapositive 3"/>
+          <p:cNvSpPr>
+            <a:spLocks noGrp="1"/>
+          </p:cNvSpPr>
+          <p:nvPr>
+            <p:ph type="sldNum" sz="quarter" idx="5"/>
+          </p:nvPr>
+        </p:nvSpPr>
+        <p:spPr/>
+        <p:txBody>
+          <a:bodyPr/>
+          <a:lstStyle/>
+          <a:p>
+            <a:pPr rtl="0"/>
+            <a:fld id="{DF61EA0F-A667-4B49-8422-0062BC55E249}" type="slidenum">
+              <a:rPr lang="fr-FR" noProof="1" dirty="0" smtClean="0"/>
+              <a:t>30</a:t>
+            </a:fld>
+            <a:endParaRPr lang="fr-FR" noProof="1"/>
+          </a:p>
+        </p:txBody>
+      </p:sp>
+    </p:spTree>
+    <p:extLst>
+      <p:ext uri="{BB962C8B-B14F-4D97-AF65-F5344CB8AC3E}">
+        <p14:creationId xmlns:p14="http://schemas.microsoft.com/office/powerpoint/2010/main" val="1359022272"/>
+      </p:ext>
+    </p:extLst>
+  </p:cSld>
+  <p:clrMapOvr>
+    <a:masterClrMapping/>
+  </p:clrMapOvr>
+</p:notes>
+</file>
+
+<file path=ppt/notesSlides/notesSlide31.xml><?xml version="1.0" encoding="utf-8"?>
+<p:notes xmlns:a="http://schemas.openxmlformats.org/drawingml/2006/main" xmlns:r="http://schemas.openxmlformats.org/officeDocument/2006/relationships" xmlns:p="http://schemas.openxmlformats.org/presentationml/2006/main">
+  <p:cSld>
+    <p:spTree>
+      <p:nvGrpSpPr>
+        <p:cNvPr id="1" name=""/>
+        <p:cNvGrpSpPr/>
+        <p:nvPr/>
+      </p:nvGrpSpPr>
+      <p:grpSpPr>
+        <a:xfrm>
+          <a:off x="0" y="0"/>
+          <a:ext cx="0" cy="0"/>
+          <a:chOff x="0" y="0"/>
+          <a:chExt cx="0" cy="0"/>
+        </a:xfrm>
+      </p:grpSpPr>
+      <p:sp>
+        <p:nvSpPr>
+          <p:cNvPr id="2" name="Espace réservé de l'image des diapositives 1"/>
+          <p:cNvSpPr>
+            <a:spLocks noGrp="1" noRot="1" noChangeAspect="1"/>
+          </p:cNvSpPr>
+          <p:nvPr>
+            <p:ph type="sldImg"/>
+          </p:nvPr>
+        </p:nvSpPr>
+        <p:spPr/>
+      </p:sp>
+      <p:sp>
+        <p:nvSpPr>
+          <p:cNvPr id="3" name="Espace réservé des notes 2"/>
+          <p:cNvSpPr>
+            <a:spLocks noGrp="1"/>
+          </p:cNvSpPr>
+          <p:nvPr>
+            <p:ph type="body" idx="1"/>
+          </p:nvPr>
+        </p:nvSpPr>
+        <p:spPr/>
+        <p:txBody>
+          <a:bodyPr/>
+          <a:lstStyle/>
+          <a:p>
+            <a:endParaRPr lang="fr-FR" noProof="1"/>
+          </a:p>
+        </p:txBody>
+      </p:sp>
+      <p:sp>
+        <p:nvSpPr>
+          <p:cNvPr id="4" name="Espace réservé du numéro de diapositive 3"/>
+          <p:cNvSpPr>
+            <a:spLocks noGrp="1"/>
+          </p:cNvSpPr>
+          <p:nvPr>
+            <p:ph type="sldNum" sz="quarter" idx="5"/>
+          </p:nvPr>
+        </p:nvSpPr>
+        <p:spPr/>
+        <p:txBody>
+          <a:bodyPr/>
+          <a:lstStyle/>
+          <a:p>
+            <a:pPr rtl="0"/>
+            <a:fld id="{DF61EA0F-A667-4B49-8422-0062BC55E249}" type="slidenum">
+              <a:rPr lang="fr-FR" noProof="1" dirty="0" smtClean="0"/>
+              <a:t>31</a:t>
+            </a:fld>
+            <a:endParaRPr lang="fr-FR" noProof="1"/>
+          </a:p>
+        </p:txBody>
+      </p:sp>
+    </p:spTree>
+    <p:extLst>
+      <p:ext uri="{BB962C8B-B14F-4D97-AF65-F5344CB8AC3E}">
+        <p14:creationId xmlns:p14="http://schemas.microsoft.com/office/powerpoint/2010/main" val="2594538779"/>
       </p:ext>
     </p:extLst>
   </p:cSld>
@@ -12354,7 +12223,7 @@
         <p:spPr>
           <a:xfrm>
             <a:off x="521207" y="1674674"/>
-            <a:ext cx="9790161" cy="1477328"/>
+            <a:ext cx="9790161" cy="2031325"/>
           </a:xfrm>
           <a:prstGeom prst="rect">
             <a:avLst/>
@@ -12373,7 +12242,7 @@
             </a:pPr>
             <a:r>
               <a:rPr lang="fr-FR" dirty="0"/>
-              <a:t>Pagination sur requête avec une réponse « conséquente » (voir section ad hoc) qui nécessite des jointures</a:t>
+              <a:t>Je filtre sur une entité particulière et je récupère l’arbre, c’est le cas que nous allons traiter dans le slide suivant !</a:t>
             </a:r>
           </a:p>
           <a:p>
@@ -12388,10 +12257,20 @@
               <a:buFont typeface="Wingdings" panose="05000000000000000000" pitchFamily="2" charset="2"/>
               <a:buChar char="Ø"/>
             </a:pPr>
+            <a:endParaRPr lang="fr-FR" dirty="0"/>
+          </a:p>
+          <a:p>
+            <a:pPr marL="285750" indent="-285750">
+              <a:buFont typeface="Wingdings" panose="05000000000000000000" pitchFamily="2" charset="2"/>
+              <a:buChar char="Ø"/>
+            </a:pPr>
             <a:r>
               <a:rPr lang="fr-FR" dirty="0"/>
-              <a:t>Je filtre sur une entité particulière et je récupère l’arbre, c’est le cas que nous allons traiter dans le slide suivant !</a:t>
-            </a:r>
+              <a:t>Pagination sur requête avec une réponse « conséquente » (voir section ad hoc) qui nécessite des jointures</a:t>
+            </a:r>
+          </a:p>
+          <a:p>
+            <a:endParaRPr lang="fr-FR" dirty="0"/>
           </a:p>
         </p:txBody>
       </p:sp>
@@ -12449,7 +12328,7 @@
                                         <p:tgtEl>
                                           <p:spTgt spid="5">
                                             <p:txEl>
-                                              <p:pRg st="0" end="0"/>
+                                              <p:pRg st="3" end="3"/>
                                             </p:txEl>
                                           </p:spTgt>
                                         </p:tgtEl>
@@ -12498,7 +12377,7 @@
                                         <p:tgtEl>
                                           <p:spTgt spid="5">
                                             <p:txEl>
-                                              <p:pRg st="2" end="2"/>
+                                              <p:pRg st="0" end="0"/>
                                             </p:txEl>
                                           </p:spTgt>
                                         </p:tgtEl>
@@ -19104,7 +18983,7 @@
                 <a:effectLst/>
                 <a:latin typeface="Fira Code"/>
               </a:rPr>
-              <a:t>findAllPagination</a:t>
+              <a:t>findAll</a:t>
             </a:r>
             <a:r>
               <a:rPr kumimoji="0" lang="fr-FR" altLang="fr-FR" sz="1400" b="0" i="0" u="none" strike="noStrike" cap="none" normalizeH="0" baseline="0" dirty="0">
@@ -20357,21 +20236,13 @@
             </a:endParaRPr>
           </a:p>
           <a:p>
-            <a:pPr marL="0" marR="0" lvl="0" indent="0" algn="l" defTabSz="914400" rtl="0" eaLnBrk="0" fontAlgn="base" latinLnBrk="0" hangingPunct="0">
-              <a:lnSpc>
-                <a:spcPct val="100000"/>
-              </a:lnSpc>
+            <a:pPr lvl="0" eaLnBrk="0" fontAlgn="base" hangingPunct="0">
               <a:spcBef>
                 <a:spcPct val="0"/>
               </a:spcBef>
               <a:spcAft>
                 <a:spcPct val="0"/>
               </a:spcAft>
-              <a:buClrTx/>
-              <a:buSzTx/>
-              <a:buFontTx/>
-              <a:buNone/>
-              <a:tabLst/>
             </a:pPr>
             <a:r>
               <a:rPr kumimoji="0" lang="fr-FR" altLang="fr-FR" sz="1400" b="0" i="1" u="none" strike="noStrike" cap="none" normalizeH="0" baseline="0" dirty="0">
@@ -20661,17 +20532,13 @@
               <a:t>findAllSlice</a:t>
             </a:r>
             <a:r>
-              <a:rPr kumimoji="0" lang="fr-FR" altLang="fr-FR" sz="1400" b="0" i="0" u="none" strike="noStrike" cap="none" normalizeH="0" baseline="0" dirty="0">
-                <a:ln>
-                  <a:noFill/>
-                </a:ln>
-                <a:solidFill>
-                  <a:srgbClr val="080808"/>
-                </a:solidFill>
-                <a:effectLst/>
-                <a:latin typeface="Fira Code"/>
-              </a:rPr>
-              <a:t>(</a:t>
+              <a:rPr lang="fr-FR" altLang="fr-FR" sz="1400" dirty="0">
+                <a:solidFill>
+                  <a:srgbClr val="080808"/>
+                </a:solidFill>
+                <a:latin typeface="Fira Code"/>
+              </a:rPr>
+              <a:t>(Type param, </a:t>
             </a:r>
             <a:r>
               <a:rPr kumimoji="0" lang="fr-FR" altLang="fr-FR" sz="1400" b="0" i="0" u="none" strike="noStrike" cap="none" normalizeH="0" baseline="0" dirty="0" err="1">
@@ -21876,8 +21743,8 @@
         </p:nvSpPr>
         <p:spPr bwMode="auto">
           <a:xfrm>
-            <a:off x="636494" y="2251645"/>
-            <a:ext cx="10919012" cy="2031325"/>
+            <a:off x="636494" y="2390144"/>
+            <a:ext cx="10919012" cy="1754326"/>
           </a:xfrm>
           <a:prstGeom prst="rect">
             <a:avLst/>
@@ -22311,12 +22178,12 @@
                   <a:noFill/>
                 </a:ln>
                 <a:solidFill>
-                  <a:srgbClr val="9E880D"/>
-                </a:solidFill>
-                <a:effectLst/>
-                <a:latin typeface="Fira Code"/>
-              </a:rPr>
-              <a:t>@Query</a:t>
+                  <a:srgbClr val="000000"/>
+                </a:solidFill>
+                <a:effectLst/>
+                <a:latin typeface="Fira Code"/>
+              </a:rPr>
+              <a:t>Page</a:t>
             </a:r>
             <a:r>
               <a:rPr kumimoji="0" lang="fr-FR" altLang="fr-FR" b="0" i="0" u="none" strike="noStrike" cap="none" normalizeH="0" baseline="0" dirty="0">
@@ -22329,7 +22196,20 @@
                 <a:effectLst/>
                 <a:latin typeface="Fira Code"/>
               </a:rPr>
-              <a:t>(</a:t>
+              <a:t>&lt;</a:t>
+            </a:r>
+            <a:r>
+              <a:rPr kumimoji="0" lang="fr-FR" altLang="fr-FR" b="0" i="0" u="none" strike="noStrike" cap="none" normalizeH="0" baseline="0" dirty="0" err="1">
+                <a:ln>
+                  <a:noFill/>
+                </a:ln>
+                <a:solidFill>
+                  <a:srgbClr val="000000"/>
+                </a:solidFill>
+                <a:effectLst/>
+                <a:latin typeface="Fira Code"/>
+              </a:rPr>
+              <a:t>School</a:t>
             </a:r>
             <a:r>
               <a:rPr kumimoji="0" lang="fr-FR" altLang="fr-FR" b="0" i="0" u="none" strike="noStrike" cap="none" normalizeH="0" baseline="0" dirty="0">
@@ -22337,12 +22217,12 @@
                   <a:noFill/>
                 </a:ln>
                 <a:solidFill>
-                  <a:srgbClr val="067D17"/>
-                </a:solidFill>
-                <a:effectLst/>
-                <a:latin typeface="Fira Code"/>
-              </a:rPr>
-              <a:t>"SELECT sc FROM </a:t>
+                  <a:srgbClr val="080808"/>
+                </a:solidFill>
+                <a:effectLst/>
+                <a:latin typeface="Fira Code"/>
+              </a:rPr>
+              <a:t>&gt; </a:t>
             </a:r>
             <a:r>
               <a:rPr kumimoji="0" lang="fr-FR" altLang="fr-FR" b="0" i="0" u="none" strike="noStrike" cap="none" normalizeH="0" baseline="0" dirty="0" err="1">
@@ -22350,115 +22230,12 @@
                   <a:noFill/>
                 </a:ln>
                 <a:solidFill>
-                  <a:srgbClr val="067D17"/>
-                </a:solidFill>
-                <a:effectLst/>
-                <a:latin typeface="Fira Code"/>
-              </a:rPr>
-              <a:t>School</a:t>
-            </a:r>
-            <a:r>
-              <a:rPr kumimoji="0" lang="fr-FR" altLang="fr-FR" b="0" i="0" u="none" strike="noStrike" cap="none" normalizeH="0" baseline="0" dirty="0">
-                <a:ln>
-                  <a:noFill/>
-                </a:ln>
-                <a:solidFill>
-                  <a:srgbClr val="067D17"/>
-                </a:solidFill>
-                <a:effectLst/>
-                <a:latin typeface="Fira Code"/>
-              </a:rPr>
-              <a:t> sc"</a:t>
-            </a:r>
-            <a:r>
-              <a:rPr kumimoji="0" lang="fr-FR" altLang="fr-FR" b="0" i="0" u="none" strike="noStrike" cap="none" normalizeH="0" baseline="0" dirty="0">
-                <a:ln>
-                  <a:noFill/>
-                </a:ln>
-                <a:solidFill>
-                  <a:srgbClr val="080808"/>
-                </a:solidFill>
-                <a:effectLst/>
-                <a:latin typeface="Fira Code"/>
-              </a:rPr>
-              <a:t>)</a:t>
-            </a:r>
-            <a:br>
-              <a:rPr kumimoji="0" lang="fr-FR" altLang="fr-FR" b="0" i="0" u="none" strike="noStrike" cap="none" normalizeH="0" baseline="0" dirty="0">
-                <a:ln>
-                  <a:noFill/>
-                </a:ln>
-                <a:solidFill>
-                  <a:srgbClr val="080808"/>
-                </a:solidFill>
-                <a:effectLst/>
-                <a:latin typeface="Fira Code"/>
-              </a:rPr>
-            </a:br>
-            <a:r>
-              <a:rPr kumimoji="0" lang="fr-FR" altLang="fr-FR" b="0" i="0" u="none" strike="noStrike" cap="none" normalizeH="0" baseline="0" dirty="0">
-                <a:ln>
-                  <a:noFill/>
-                </a:ln>
-                <a:solidFill>
-                  <a:srgbClr val="000000"/>
-                </a:solidFill>
-                <a:effectLst/>
-                <a:latin typeface="Fira Code"/>
-              </a:rPr>
-              <a:t>Page</a:t>
-            </a:r>
-            <a:r>
-              <a:rPr kumimoji="0" lang="fr-FR" altLang="fr-FR" b="0" i="0" u="none" strike="noStrike" cap="none" normalizeH="0" baseline="0" dirty="0">
-                <a:ln>
-                  <a:noFill/>
-                </a:ln>
-                <a:solidFill>
-                  <a:srgbClr val="080808"/>
-                </a:solidFill>
-                <a:effectLst/>
-                <a:latin typeface="Fira Code"/>
-              </a:rPr>
-              <a:t>&lt;</a:t>
-            </a:r>
-            <a:r>
-              <a:rPr kumimoji="0" lang="fr-FR" altLang="fr-FR" b="0" i="0" u="none" strike="noStrike" cap="none" normalizeH="0" baseline="0" dirty="0" err="1">
-                <a:ln>
-                  <a:noFill/>
-                </a:ln>
-                <a:solidFill>
-                  <a:srgbClr val="000000"/>
-                </a:solidFill>
-                <a:effectLst/>
-                <a:latin typeface="Fira Code"/>
-              </a:rPr>
-              <a:t>School</a:t>
-            </a:r>
-            <a:r>
-              <a:rPr kumimoji="0" lang="fr-FR" altLang="fr-FR" b="0" i="0" u="none" strike="noStrike" cap="none" normalizeH="0" baseline="0" dirty="0">
-                <a:ln>
-                  <a:noFill/>
-                </a:ln>
-                <a:solidFill>
-                  <a:srgbClr val="080808"/>
-                </a:solidFill>
-                <a:effectLst/>
-                <a:latin typeface="Fira Code"/>
-              </a:rPr>
-              <a:t>&gt; </a:t>
-            </a:r>
-            <a:r>
-              <a:rPr kumimoji="0" lang="fr-FR" altLang="fr-FR" b="0" i="0" u="none" strike="noStrike" cap="none" normalizeH="0" baseline="0" dirty="0" err="1">
-                <a:ln>
-                  <a:noFill/>
-                </a:ln>
-                <a:solidFill>
                   <a:srgbClr val="00627A"/>
                 </a:solidFill>
                 <a:effectLst/>
                 <a:latin typeface="Fira Code"/>
               </a:rPr>
-              <a:t>findAllPagination</a:t>
+              <a:t>findAll</a:t>
             </a:r>
             <a:r>
               <a:rPr kumimoji="0" lang="fr-FR" altLang="fr-FR" b="0" i="0" u="none" strike="noStrike" cap="none" normalizeH="0" baseline="0" dirty="0">
@@ -23595,8 +23372,30 @@
           <a:p>
             <a:r>
               <a:rPr lang="fr-FR" dirty="0"/>
-              <a:t>Pourquoi faire ? Pour sortir du modèle relationnel et faire des requêtes très rapides (Dashboard etc…)</a:t>
-            </a:r>
+              <a:t>Pourquoi faire ? Pour sortir du modèle relationnel et faire des requêtes très rapides (Dashboard etc…) </a:t>
+            </a:r>
+            <a:r>
+              <a:rPr lang="fr-FR" dirty="0">
+                <a:sym typeface="Wingdings" panose="05000000000000000000" pitchFamily="2" charset="2"/>
+              </a:rPr>
+              <a:t> je ne récupère </a:t>
+            </a:r>
+            <a:r>
+              <a:rPr lang="fr-FR" u="sng" dirty="0">
+                <a:solidFill>
+                  <a:srgbClr val="C00000"/>
+                </a:solidFill>
+                <a:sym typeface="Wingdings" panose="05000000000000000000" pitchFamily="2" charset="2"/>
+              </a:rPr>
+              <a:t>que</a:t>
+            </a:r>
+            <a:r>
+              <a:rPr lang="fr-FR" dirty="0">
+                <a:sym typeface="Wingdings" panose="05000000000000000000" pitchFamily="2" charset="2"/>
+              </a:rPr>
+              <a:t> les données nécessaires</a:t>
+            </a:r>
+            <a:endParaRPr lang="fr-FR" dirty="0"/>
           </a:p>
           <a:p>
             <a:endParaRPr lang="fr-FR" dirty="0"/>
@@ -29204,7 +29003,13 @@
           <p:cNvGraphicFramePr>
             <a:graphicFrameLocks noGrp="1"/>
           </p:cNvGraphicFramePr>
-          <p:nvPr/>
+          <p:nvPr>
+            <p:extLst>
+              <p:ext uri="{D42A27DB-BD31-4B8C-83A1-F6EECF244321}">
+                <p14:modId xmlns:p14="http://schemas.microsoft.com/office/powerpoint/2010/main" val="3287725693"/>
+              </p:ext>
+            </p:extLst>
+          </p:nvPr>
         </p:nvGraphicFramePr>
         <p:xfrm>
           <a:off x="687421" y="1284051"/>
@@ -29717,7 +29522,7 @@
                       <a:pPr algn="ctr"/>
                       <a:r>
                         <a:rPr lang="fr-FR" sz="1400" dirty="0"/>
-                        <a:t>(tape dans toutes les tables, &gt; 5, 6 jointures)</a:t>
+                        <a:t>(tape dans toutes les tables, &gt; 6 jointures)</a:t>
                       </a:r>
                     </a:p>
                     <a:p>
@@ -32027,7 +31832,7 @@
                             </p:stCondLst>
                             <p:childTnLst>
                               <p:par>
-                                <p:cTn id="5" presetID="1" presetClass="entr" presetSubtype="0" fill="hold" nodeType="clickEffect">
+                                <p:cTn id="5" presetID="1" presetClass="entr" presetSubtype="0" fill="hold" grpId="0" nodeType="clickEffect">
                                   <p:stCondLst>
                                     <p:cond delay="0"/>
                                   </p:stCondLst>
@@ -32040,11 +31845,7 @@
                                           </p:stCondLst>
                                         </p:cTn>
                                         <p:tgtEl>
-                                          <p:spTgt spid="2">
-                                            <p:txEl>
-                                              <p:pRg st="0" end="0"/>
-                                            </p:txEl>
-                                          </p:spTgt>
+                                          <p:spTgt spid="6"/>
                                         </p:tgtEl>
                                         <p:attrNameLst>
                                           <p:attrName>style.visibility</p:attrName>
@@ -32084,7 +31885,128 @@
         </p:cTn>
       </p:par>
     </p:tnLst>
+    <p:bldLst>
+      <p:bldP spid="6" grpId="0" animBg="1"/>
+    </p:bldLst>
   </p:timing>
+</p:sld>
+</file>
+
+<file path=ppt/slides/slide31.xml><?xml version="1.0" encoding="utf-8"?>
+<p:sld xmlns:a="http://schemas.openxmlformats.org/drawingml/2006/main" xmlns:r="http://schemas.openxmlformats.org/officeDocument/2006/relationships" xmlns:p="http://schemas.openxmlformats.org/presentationml/2006/main">
+  <p:cSld>
+    <p:spTree>
+      <p:nvGrpSpPr>
+        <p:cNvPr id="1" name=""/>
+        <p:cNvGrpSpPr/>
+        <p:nvPr/>
+      </p:nvGrpSpPr>
+      <p:grpSpPr>
+        <a:xfrm>
+          <a:off x="0" y="0"/>
+          <a:ext cx="0" cy="0"/>
+          <a:chOff x="0" y="0"/>
+          <a:chExt cx="0" cy="0"/>
+        </a:xfrm>
+      </p:grpSpPr>
+      <p:sp>
+        <p:nvSpPr>
+          <p:cNvPr id="4" name="Titre 3"/>
+          <p:cNvSpPr>
+            <a:spLocks noGrp="1"/>
+          </p:cNvSpPr>
+          <p:nvPr>
+            <p:ph type="title"/>
+          </p:nvPr>
+        </p:nvSpPr>
+        <p:spPr>
+          <a:xfrm>
+            <a:off x="521207" y="448056"/>
+            <a:ext cx="7783344" cy="640080"/>
+          </a:xfrm>
+        </p:spPr>
+        <p:txBody>
+          <a:bodyPr rtlCol="0">
+            <a:normAutofit/>
+          </a:bodyPr>
+          <a:lstStyle/>
+          <a:p>
+            <a:pPr rtl="0"/>
+            <a:r>
+              <a:rPr lang="fr-FR" noProof="1">
+                <a:latin typeface="Segoe UI Light" panose="020B0502040204020203" pitchFamily="34" charset="0"/>
+                <a:cs typeface="Segoe UI Light" panose="020B0502040204020203" pitchFamily="34" charset="0"/>
+              </a:rPr>
+              <a:t>Questions ?</a:t>
+            </a:r>
+          </a:p>
+        </p:txBody>
+      </p:sp>
+      <p:pic>
+        <p:nvPicPr>
+          <p:cNvPr id="1026" name="Picture 2" descr="La comédie «lourde» à la française, un cinéma social | Slate.fr">
+            <a:extLst>
+              <a:ext uri="{FF2B5EF4-FFF2-40B4-BE49-F238E27FC236}">
+                <a16:creationId xmlns:a16="http://schemas.microsoft.com/office/drawing/2014/main" id="{4625B0D1-5AEC-4614-BD48-24C59880CB52}"/>
+              </a:ext>
+            </a:extLst>
+          </p:cNvPr>
+          <p:cNvPicPr>
+            <a:picLocks noChangeAspect="1" noChangeArrowheads="1" noCrop="1"/>
+          </p:cNvPicPr>
+          <p:nvPr/>
+        </p:nvPicPr>
+        <p:blipFill>
+          <a:blip r:embed="rId3">
+            <a:extLst>
+              <a:ext uri="{28A0092B-C50C-407E-A947-70E740481C1C}">
+                <a14:useLocalDpi xmlns:a14="http://schemas.microsoft.com/office/drawing/2010/main" val="0"/>
+              </a:ext>
+            </a:extLst>
+          </a:blip>
+          <a:srcRect/>
+          <a:stretch>
+            <a:fillRect/>
+          </a:stretch>
+        </p:blipFill>
+        <p:spPr bwMode="auto">
+          <a:xfrm>
+            <a:off x="619341" y="1709737"/>
+            <a:ext cx="10953318" cy="4462463"/>
+          </a:xfrm>
+          <a:prstGeom prst="rect">
+            <a:avLst/>
+          </a:prstGeom>
+          <a:noFill/>
+          <a:extLst>
+            <a:ext uri="{909E8E84-426E-40DD-AFC4-6F175D3DCCD1}">
+              <a14:hiddenFill xmlns:a14="http://schemas.microsoft.com/office/drawing/2010/main">
+                <a:solidFill>
+                  <a:srgbClr val="FFFFFF"/>
+                </a:solidFill>
+              </a14:hiddenFill>
+            </a:ext>
+          </a:extLst>
+        </p:spPr>
+      </p:pic>
+    </p:spTree>
+    <p:extLst>
+      <p:ext uri="{BB962C8B-B14F-4D97-AF65-F5344CB8AC3E}">
+        <p14:creationId xmlns:p14="http://schemas.microsoft.com/office/powerpoint/2010/main" val="809557882"/>
+      </p:ext>
+    </p:extLst>
+  </p:cSld>
+  <p:clrMapOvr>
+    <a:masterClrMapping/>
+  </p:clrMapOvr>
+  <mc:AlternateContent xmlns:mc="http://schemas.openxmlformats.org/markup-compatibility/2006" xmlns:p14="http://schemas.microsoft.com/office/powerpoint/2010/main">
+    <mc:Choice Requires="p14">
+      <p:transition p14:dur="10"/>
+    </mc:Choice>
+    <mc:Fallback xmlns="">
+      <p:transition/>
+    </mc:Fallback>
+  </mc:AlternateContent>
 </p:sld>
 </file>
 
@@ -41422,15 +41344,6 @@
 </file>
 
 <file path=customXml/item1.xml><?xml version="1.0" encoding="utf-8"?>
-<?mso-contentType ?>
-<FormTemplates xmlns="http://schemas.microsoft.com/sharepoint/v3/contenttype/forms">
-  <Display>DocumentLibraryForm</Display>
-  <Edit>DocumentLibraryForm</Edit>
-  <New>DocumentLibraryForm</New>
-</FormTemplates>
-</file>
-
-<file path=customXml/item2.xml><?xml version="1.0" encoding="utf-8"?>
 <ct:contentTypeSchema xmlns:ct="http://schemas.microsoft.com/office/2006/metadata/contentType" xmlns:ma="http://schemas.microsoft.com/office/2006/metadata/properties/metaAttributes" ct:_="" ma:_="" ma:contentTypeName="Document" ma:contentTypeID="0x01010079F111ED35F8CC479449609E8A0923A6" ma:contentTypeVersion="12" ma:contentTypeDescription="Create a new document." ma:contentTypeScope="" ma:versionID="a8a52e8c320b9a064ae3583ae3861c92">
   <xsd:schema xmlns:xsd="http://www.w3.org/2001/XMLSchema" xmlns:xs="http://www.w3.org/2001/XMLSchema" xmlns:p="http://schemas.microsoft.com/office/2006/metadata/properties" xmlns:ns2="71af3243-3dd4-4a8d-8c0d-dd76da1f02a5" xmlns:ns3="16c05727-aa75-4e4a-9b5f-8a80a1165891" targetNamespace="http://schemas.microsoft.com/office/2006/metadata/properties" ma:root="true" ma:fieldsID="88020cb39231a0945110f9cd888b521a" ns2:_="" ns3:_="">
     <xsd:import namespace="71af3243-3dd4-4a8d-8c0d-dd76da1f02a5"/>
@@ -41651,6 +41564,15 @@
 </ct:contentTypeSchema>
 </file>
 
+<file path=customXml/item2.xml><?xml version="1.0" encoding="utf-8"?>
+<?mso-contentType ?>
+<FormTemplates xmlns="http://schemas.microsoft.com/sharepoint/v3/contenttype/forms">
+  <Display>DocumentLibraryForm</Display>
+  <Edit>DocumentLibraryForm</Edit>
+  <New>DocumentLibraryForm</New>
+</FormTemplates>
+</file>
+
 <file path=customXml/item3.xml><?xml version="1.0" encoding="utf-8"?>
 <p:properties xmlns:p="http://schemas.microsoft.com/office/2006/metadata/properties" xmlns:xsi="http://www.w3.org/2001/XMLSchema-instance" xmlns:pc="http://schemas.microsoft.com/office/infopath/2007/PartnerControls">
   <documentManagement>
@@ -41661,14 +41583,6 @@
 </file>
 
 <file path=customXml/itemProps1.xml><?xml version="1.0" encoding="utf-8"?>
-<ds:datastoreItem xmlns:ds="http://schemas.openxmlformats.org/officeDocument/2006/customXml" ds:itemID="{7EE8C63A-4744-4DE4-BB49-0FF0B5375C60}">
-  <ds:schemaRefs>
-    <ds:schemaRef ds:uri="http://schemas.microsoft.com/sharepoint/v3/contenttype/forms"/>
-  </ds:schemaRefs>
-</ds:datastoreItem>
-</file>
-
-<file path=customXml/itemProps2.xml><?xml version="1.0" encoding="utf-8"?>
 <ds:datastoreItem xmlns:ds="http://schemas.openxmlformats.org/officeDocument/2006/customXml" ds:itemID="{FD7FC771-7DFE-49DA-B577-71181BFBCB2E}">
   <ds:schemaRefs>
     <ds:schemaRef ds:uri="http://schemas.microsoft.com/office/2006/metadata/contentType"/>
@@ -41683,6 +41597,14 @@
     <ds:schemaRef ds:uri="http://purl.org/dc/elements/1.1/"/>
     <ds:schemaRef ds:uri="http://purl.org/dc/terms/"/>
     <ds:schemaRef ds:uri="http://schemas.microsoft.com/internal/obd"/>
+  </ds:schemaRefs>
+</ds:datastoreItem>
+</file>
+
+<file path=customXml/itemProps2.xml><?xml version="1.0" encoding="utf-8"?>
+<ds:datastoreItem xmlns:ds="http://schemas.openxmlformats.org/officeDocument/2006/customXml" ds:itemID="{7EE8C63A-4744-4DE4-BB49-0FF0B5375C60}">
+  <ds:schemaRefs>
+    <ds:schemaRef ds:uri="http://schemas.microsoft.com/sharepoint/v3/contenttype/forms"/>
   </ds:schemaRefs>
 </ds:datastoreItem>
 </file>

</xml_diff>